<commit_message>
Show full grab-to-buy chain with highlighted fix, screenshots on left
Co-Authored-By: Claude Opus 5.5 <noreply@anthropic.com>
Claude-Session: https://claude.ai/code/session_011iFrL2Hfizgp6kYckDtNGc
</commit_message>
<xml_diff>
--- a/抢转买页.pptx
+++ b/抢转买页.pptx
@@ -5656,97 +5656,9 @@
           </a:p>
         </p:txBody>
       </p:sp>
-      <p:sp>
-        <p:nvSpPr>
-          <p:cNvPr id="4" name="Rounded Rectangle 3"/>
-          <p:cNvSpPr/>
-          <p:nvPr/>
-        </p:nvSpPr>
-        <p:spPr>
-          <a:xfrm>
-            <a:off x="457200" y="1554480"/>
-            <a:ext cx="3063240" cy="914400"/>
-          </a:xfrm>
-          <a:prstGeom prst="roundRect">
-            <a:avLst>
-              <a:gd name="adj" fmla="val 6000"/>
-            </a:avLst>
-          </a:prstGeom>
-          <a:solidFill>
-            <a:srgbClr val="F5F9FF"/>
-          </a:solidFill>
-          <a:ln w="12700">
-            <a:solidFill>
-              <a:srgbClr val="D3E2FB"/>
-            </a:solidFill>
-          </a:ln>
-          <a:effectLst/>
-        </p:spPr>
-        <p:style>
-          <a:lnRef idx="1">
-            <a:schemeClr val="accent1"/>
-          </a:lnRef>
-          <a:fillRef idx="3">
-            <a:schemeClr val="accent1"/>
-          </a:fillRef>
-          <a:effectRef idx="2">
-            <a:schemeClr val="accent1"/>
-          </a:effectRef>
-          <a:fontRef idx="minor">
-            <a:schemeClr val="lt1"/>
-          </a:fontRef>
-        </p:style>
-        <p:txBody>
-          <a:bodyPr rtlCol="0" anchor="ctr"/>
-          <a:lstStyle/>
-          <a:p/>
-        </p:txBody>
-      </p:sp>
-      <p:sp>
-        <p:nvSpPr>
-          <p:cNvPr id="5" name="icon-circle"/>
-          <p:cNvSpPr/>
-          <p:nvPr/>
-        </p:nvSpPr>
-        <p:spPr>
-          <a:xfrm>
-            <a:off x="685800" y="1737360"/>
-            <a:ext cx="548640" cy="548640"/>
-          </a:xfrm>
-          <a:prstGeom prst="ellipse">
-            <a:avLst/>
-          </a:prstGeom>
-          <a:solidFill>
-            <a:srgbClr val="287DFA"/>
-          </a:solidFill>
-          <a:ln>
-            <a:noFill/>
-          </a:ln>
-          <a:effectLst/>
-        </p:spPr>
-        <p:style>
-          <a:lnRef idx="1">
-            <a:schemeClr val="accent1"/>
-          </a:lnRef>
-          <a:fillRef idx="3">
-            <a:schemeClr val="accent1"/>
-          </a:fillRef>
-          <a:effectRef idx="2">
-            <a:schemeClr val="accent1"/>
-          </a:effectRef>
-          <a:fontRef idx="minor">
-            <a:schemeClr val="lt1"/>
-          </a:fontRef>
-        </p:style>
-        <p:txBody>
-          <a:bodyPr rtlCol="0" anchor="ctr"/>
-          <a:lstStyle/>
-          <a:p/>
-        </p:txBody>
-      </p:sp>
       <p:pic>
         <p:nvPicPr>
-          <p:cNvPr id="6" name="Picture 5" descr="FaListCheck_w.png"/>
+          <p:cNvPr id="4" name="真实截图-抢必走" descr="qbz.png"/>
           <p:cNvPicPr>
             <a:picLocks noChangeAspect="1"/>
           </p:cNvPicPr>
@@ -5760,973 +5672,7 @@
         </p:blipFill>
         <p:spPr>
           <a:xfrm>
-            <a:off x="822960" y="1874519"/>
-            <a:ext cx="274320" cy="274320"/>
-          </a:xfrm>
-          <a:prstGeom prst="rect">
-            <a:avLst/>
-          </a:prstGeom>
-        </p:spPr>
-      </p:pic>
-      <p:sp>
-        <p:nvSpPr>
-          <p:cNvPr id="7" name="TextBox 6"/>
-          <p:cNvSpPr txBox="1"/>
-          <p:nvPr/>
-        </p:nvSpPr>
-        <p:spPr>
-          <a:xfrm>
-            <a:off x="1371600" y="1554480"/>
-            <a:ext cx="2057400" cy="914400"/>
-          </a:xfrm>
-          <a:prstGeom prst="rect">
-            <a:avLst/>
-          </a:prstGeom>
-          <a:noFill/>
-        </p:spPr>
-        <p:txBody>
-          <a:bodyPr wrap="square" lIns="0" rIns="0" tIns="0" bIns="0" anchor="ctr">
-            <a:spAutoFit/>
-          </a:bodyPr>
-          <a:lstStyle/>
-          <a:p>
-            <a:pPr algn="l"/>
-            <a:r>
-              <a:rPr sz="1400" b="1">
-                <a:solidFill>
-                  <a:srgbClr val="15315E"/>
-                </a:solidFill>
-                <a:latin typeface="微软雅黑"/>
-                <a:ea typeface="微软雅黑"/>
-                <a:cs typeface="微软雅黑"/>
-              </a:rPr>
-              <a:t>推荐可立即出票的</a:t>
-            </a:r>
-          </a:p>
-          <a:p>
-            <a:pPr algn="l">
-              <a:spcBef>
-                <a:spcPts val="0"/>
-              </a:spcBef>
-            </a:pPr>
-            <a:r>
-              <a:rPr sz="1400" b="1">
-                <a:solidFill>
-                  <a:srgbClr val="15315E"/>
-                </a:solidFill>
-                <a:latin typeface="微软雅黑"/>
-                <a:ea typeface="微软雅黑"/>
-                <a:cs typeface="微软雅黑"/>
-              </a:rPr>
-              <a:t>替代方案</a:t>
-            </a:r>
-          </a:p>
-        </p:txBody>
-      </p:sp>
-      <p:sp>
-        <p:nvSpPr>
-          <p:cNvPr id="8" name="Rounded Rectangle 7"/>
-          <p:cNvSpPr/>
-          <p:nvPr/>
-        </p:nvSpPr>
-        <p:spPr>
-          <a:xfrm>
-            <a:off x="3886200" y="1554480"/>
-            <a:ext cx="3063240" cy="914400"/>
-          </a:xfrm>
-          <a:prstGeom prst="roundRect">
-            <a:avLst>
-              <a:gd name="adj" fmla="val 6000"/>
-            </a:avLst>
-          </a:prstGeom>
-          <a:solidFill>
-            <a:srgbClr val="F5F9FF"/>
-          </a:solidFill>
-          <a:ln w="12700">
-            <a:solidFill>
-              <a:srgbClr val="D3E2FB"/>
-            </a:solidFill>
-          </a:ln>
-          <a:effectLst/>
-        </p:spPr>
-        <p:style>
-          <a:lnRef idx="1">
-            <a:schemeClr val="accent1"/>
-          </a:lnRef>
-          <a:fillRef idx="3">
-            <a:schemeClr val="accent1"/>
-          </a:fillRef>
-          <a:effectRef idx="2">
-            <a:schemeClr val="accent1"/>
-          </a:effectRef>
-          <a:fontRef idx="minor">
-            <a:schemeClr val="lt1"/>
-          </a:fontRef>
-        </p:style>
-        <p:txBody>
-          <a:bodyPr rtlCol="0" anchor="ctr"/>
-          <a:lstStyle/>
-          <a:p/>
-        </p:txBody>
-      </p:sp>
-      <p:sp>
-        <p:nvSpPr>
-          <p:cNvPr id="9" name="icon-circle"/>
-          <p:cNvSpPr/>
-          <p:nvPr/>
-        </p:nvSpPr>
-        <p:spPr>
-          <a:xfrm>
-            <a:off x="4114800" y="1737360"/>
-            <a:ext cx="548640" cy="548640"/>
-          </a:xfrm>
-          <a:prstGeom prst="ellipse">
-            <a:avLst/>
-          </a:prstGeom>
-          <a:solidFill>
-            <a:srgbClr val="287DFA"/>
-          </a:solidFill>
-          <a:ln>
-            <a:noFill/>
-          </a:ln>
-          <a:effectLst/>
-        </p:spPr>
-        <p:style>
-          <a:lnRef idx="1">
-            <a:schemeClr val="accent1"/>
-          </a:lnRef>
-          <a:fillRef idx="3">
-            <a:schemeClr val="accent1"/>
-          </a:fillRef>
-          <a:effectRef idx="2">
-            <a:schemeClr val="accent1"/>
-          </a:effectRef>
-          <a:fontRef idx="minor">
-            <a:schemeClr val="lt1"/>
-          </a:fontRef>
-        </p:style>
-        <p:txBody>
-          <a:bodyPr rtlCol="0" anchor="ctr"/>
-          <a:lstStyle/>
-          <a:p/>
-        </p:txBody>
-      </p:sp>
-      <p:pic>
-        <p:nvPicPr>
-          <p:cNvPr id="10" name="Picture 9" descr="FaUserCheck_w.png"/>
-          <p:cNvPicPr>
-            <a:picLocks noChangeAspect="1"/>
-          </p:cNvPicPr>
-          <p:nvPr/>
-        </p:nvPicPr>
-        <p:blipFill>
-          <a:blip r:embed="rId4"/>
-          <a:stretch>
-            <a:fillRect/>
-          </a:stretch>
-        </p:blipFill>
-        <p:spPr>
-          <a:xfrm>
-            <a:off x="4251960" y="1874519"/>
-            <a:ext cx="274320" cy="274320"/>
-          </a:xfrm>
-          <a:prstGeom prst="rect">
-            <a:avLst/>
-          </a:prstGeom>
-        </p:spPr>
-      </p:pic>
-      <p:sp>
-        <p:nvSpPr>
-          <p:cNvPr id="11" name="TextBox 10"/>
-          <p:cNvSpPr txBox="1"/>
-          <p:nvPr/>
-        </p:nvSpPr>
-        <p:spPr>
-          <a:xfrm>
-            <a:off x="4800600" y="1554480"/>
-            <a:ext cx="2057400" cy="914400"/>
-          </a:xfrm>
-          <a:prstGeom prst="rect">
-            <a:avLst/>
-          </a:prstGeom>
-          <a:noFill/>
-        </p:spPr>
-        <p:txBody>
-          <a:bodyPr wrap="square" lIns="0" rIns="0" tIns="0" bIns="0" anchor="ctr">
-            <a:spAutoFit/>
-          </a:bodyPr>
-          <a:lstStyle/>
-          <a:p>
-            <a:pPr algn="l"/>
-            <a:r>
-              <a:rPr sz="1400" b="1">
-                <a:solidFill>
-                  <a:srgbClr val="15315E"/>
-                </a:solidFill>
-                <a:latin typeface="微软雅黑"/>
-                <a:ea typeface="微软雅黑"/>
-                <a:cs typeface="微软雅黑"/>
-              </a:rPr>
-              <a:t>用户让步，</a:t>
-            </a:r>
-          </a:p>
-          <a:p>
-            <a:pPr algn="l">
-              <a:spcBef>
-                <a:spcPts val="0"/>
-              </a:spcBef>
-            </a:pPr>
-            <a:r>
-              <a:rPr sz="1400" b="1">
-                <a:solidFill>
-                  <a:srgbClr val="15315E"/>
-                </a:solidFill>
-                <a:latin typeface="微软雅黑"/>
-                <a:ea typeface="微软雅黑"/>
-                <a:cs typeface="微软雅黑"/>
-              </a:rPr>
-              <a:t>接受替代方案</a:t>
-            </a:r>
-          </a:p>
-        </p:txBody>
-      </p:sp>
-      <p:sp>
-        <p:nvSpPr>
-          <p:cNvPr id="12" name="arrow"/>
-          <p:cNvSpPr/>
-          <p:nvPr/>
-        </p:nvSpPr>
-        <p:spPr>
-          <a:xfrm>
-            <a:off x="3584448" y="1874519"/>
-            <a:ext cx="256032" cy="274320"/>
-          </a:xfrm>
-          <a:prstGeom prst="rightArrow">
-            <a:avLst/>
-          </a:prstGeom>
-          <a:solidFill>
-            <a:srgbClr val="D3E2FB"/>
-          </a:solidFill>
-          <a:ln>
-            <a:noFill/>
-          </a:ln>
-          <a:effectLst/>
-        </p:spPr>
-        <p:style>
-          <a:lnRef idx="1">
-            <a:schemeClr val="accent1"/>
-          </a:lnRef>
-          <a:fillRef idx="3">
-            <a:schemeClr val="accent1"/>
-          </a:fillRef>
-          <a:effectRef idx="2">
-            <a:schemeClr val="accent1"/>
-          </a:effectRef>
-          <a:fontRef idx="minor">
-            <a:schemeClr val="lt1"/>
-          </a:fontRef>
-        </p:style>
-        <p:txBody>
-          <a:bodyPr rtlCol="0" anchor="ctr"/>
-          <a:lstStyle/>
-          <a:p/>
-        </p:txBody>
-      </p:sp>
-      <p:cxnSp>
-        <p:nvCxnSpPr>
-          <p:cNvPr id="13" name="Connector 12"/>
-          <p:cNvCxnSpPr/>
-          <p:nvPr/>
-        </p:nvCxnSpPr>
-        <p:spPr>
-          <a:xfrm>
-            <a:off x="5413248" y="2468880"/>
-            <a:ext cx="0" cy="274320"/>
-          </a:xfrm>
-          <a:prstGeom prst="line">
-            <a:avLst/>
-          </a:prstGeom>
-          <a:ln w="19050">
-            <a:solidFill>
-              <a:srgbClr val="287DFA"/>
-            </a:solidFill>
-          </a:ln>
-        </p:spPr>
-        <p:style>
-          <a:lnRef idx="2">
-            <a:schemeClr val="accent1"/>
-          </a:lnRef>
-          <a:fillRef idx="0">
-            <a:schemeClr val="accent1"/>
-          </a:fillRef>
-          <a:effectRef idx="1">
-            <a:schemeClr val="accent1"/>
-          </a:effectRef>
-          <a:fontRef idx="minor">
-            <a:schemeClr val="tx1"/>
-          </a:fontRef>
-        </p:style>
-      </p:cxnSp>
-      <p:cxnSp>
-        <p:nvCxnSpPr>
-          <p:cNvPr id="14" name="Connector 13"/>
-          <p:cNvCxnSpPr/>
-          <p:nvPr/>
-        </p:nvCxnSpPr>
-        <p:spPr>
-          <a:xfrm>
-            <a:off x="1984248" y="2743200"/>
-            <a:ext cx="3429000" cy="0"/>
-          </a:xfrm>
-          <a:prstGeom prst="line">
-            <a:avLst/>
-          </a:prstGeom>
-          <a:ln w="19050">
-            <a:solidFill>
-              <a:srgbClr val="287DFA"/>
-            </a:solidFill>
-          </a:ln>
-        </p:spPr>
-        <p:style>
-          <a:lnRef idx="2">
-            <a:schemeClr val="accent1"/>
-          </a:lnRef>
-          <a:fillRef idx="0">
-            <a:schemeClr val="accent1"/>
-          </a:fillRef>
-          <a:effectRef idx="1">
-            <a:schemeClr val="accent1"/>
-          </a:effectRef>
-          <a:fontRef idx="minor">
-            <a:schemeClr val="tx1"/>
-          </a:fontRef>
-        </p:style>
-      </p:cxnSp>
-      <p:cxnSp>
-        <p:nvCxnSpPr>
-          <p:cNvPr id="15" name="Connector 14"/>
-          <p:cNvCxnSpPr/>
-          <p:nvPr/>
-        </p:nvCxnSpPr>
-        <p:spPr>
-          <a:xfrm>
-            <a:off x="1984248" y="2743200"/>
-            <a:ext cx="0" cy="228600"/>
-          </a:xfrm>
-          <a:prstGeom prst="line">
-            <a:avLst/>
-          </a:prstGeom>
-          <a:ln w="19050">
-            <a:solidFill>
-              <a:srgbClr val="7A8599"/>
-            </a:solidFill>
-          </a:ln>
-        </p:spPr>
-        <p:style>
-          <a:lnRef idx="2">
-            <a:schemeClr val="accent1"/>
-          </a:lnRef>
-          <a:fillRef idx="0">
-            <a:schemeClr val="accent1"/>
-          </a:fillRef>
-          <a:effectRef idx="1">
-            <a:schemeClr val="accent1"/>
-          </a:effectRef>
-          <a:fontRef idx="minor">
-            <a:schemeClr val="tx1"/>
-          </a:fontRef>
-        </p:style>
-      </p:cxnSp>
-      <p:cxnSp>
-        <p:nvCxnSpPr>
-          <p:cNvPr id="16" name="Connector 15"/>
-          <p:cNvCxnSpPr/>
-          <p:nvPr/>
-        </p:nvCxnSpPr>
-        <p:spPr>
-          <a:xfrm>
-            <a:off x="5413248" y="2743200"/>
-            <a:ext cx="0" cy="228600"/>
-          </a:xfrm>
-          <a:prstGeom prst="line">
-            <a:avLst/>
-          </a:prstGeom>
-          <a:ln w="19050">
-            <a:solidFill>
-              <a:srgbClr val="287DFA"/>
-            </a:solidFill>
-          </a:ln>
-        </p:spPr>
-        <p:style>
-          <a:lnRef idx="2">
-            <a:schemeClr val="accent1"/>
-          </a:lnRef>
-          <a:fillRef idx="0">
-            <a:schemeClr val="accent1"/>
-          </a:fillRef>
-          <a:effectRef idx="1">
-            <a:schemeClr val="accent1"/>
-          </a:effectRef>
-          <a:fontRef idx="minor">
-            <a:schemeClr val="tx1"/>
-          </a:fontRef>
-        </p:style>
-      </p:cxnSp>
-      <p:sp>
-        <p:nvSpPr>
-          <p:cNvPr id="17" name="Rounded Rectangle 16"/>
-          <p:cNvSpPr/>
-          <p:nvPr/>
-        </p:nvSpPr>
-        <p:spPr>
-          <a:xfrm>
-            <a:off x="457200" y="2971800"/>
-            <a:ext cx="3063240" cy="3108960"/>
-          </a:xfrm>
-          <a:prstGeom prst="roundRect">
-            <a:avLst>
-              <a:gd name="adj" fmla="val 6000"/>
-            </a:avLst>
-          </a:prstGeom>
-          <a:solidFill>
-            <a:srgbClr val="F5F9FF"/>
-          </a:solidFill>
-          <a:ln w="12700">
-            <a:solidFill>
-              <a:srgbClr val="D3E2FB"/>
-            </a:solidFill>
-          </a:ln>
-          <a:effectLst/>
-        </p:spPr>
-        <p:style>
-          <a:lnRef idx="1">
-            <a:schemeClr val="accent1"/>
-          </a:lnRef>
-          <a:fillRef idx="3">
-            <a:schemeClr val="accent1"/>
-          </a:fillRef>
-          <a:effectRef idx="2">
-            <a:schemeClr val="accent1"/>
-          </a:effectRef>
-          <a:fontRef idx="minor">
-            <a:schemeClr val="lt1"/>
-          </a:fontRef>
-        </p:style>
-        <p:txBody>
-          <a:bodyPr rtlCol="0" anchor="ctr"/>
-          <a:lstStyle/>
-          <a:p/>
-        </p:txBody>
-      </p:sp>
-      <p:sp>
-        <p:nvSpPr>
-          <p:cNvPr id="18" name="TextBox 17"/>
-          <p:cNvSpPr txBox="1"/>
-          <p:nvPr/>
-        </p:nvSpPr>
-        <p:spPr>
-          <a:xfrm>
-            <a:off x="731520" y="3127248"/>
-            <a:ext cx="2560320" cy="365760"/>
-          </a:xfrm>
-          <a:prstGeom prst="rect">
-            <a:avLst/>
-          </a:prstGeom>
-          <a:noFill/>
-        </p:spPr>
-        <p:txBody>
-          <a:bodyPr wrap="square" lIns="0" rIns="0" tIns="0" bIns="0" anchor="t">
-            <a:spAutoFit/>
-          </a:bodyPr>
-          <a:lstStyle/>
-          <a:p>
-            <a:pPr algn="l"/>
-            <a:r>
-              <a:rPr sz="1800" b="1">
-                <a:solidFill>
-                  <a:srgbClr val="7A8599"/>
-                </a:solidFill>
-                <a:latin typeface="微软雅黑"/>
-                <a:ea typeface="微软雅黑"/>
-                <a:cs typeface="微软雅黑"/>
-              </a:rPr>
-              <a:t>之前</a:t>
-            </a:r>
-          </a:p>
-        </p:txBody>
-      </p:sp>
-      <p:sp>
-        <p:nvSpPr>
-          <p:cNvPr id="19" name="icon-circle"/>
-          <p:cNvSpPr/>
-          <p:nvPr/>
-        </p:nvSpPr>
-        <p:spPr>
-          <a:xfrm>
-            <a:off x="731520" y="3703320"/>
-            <a:ext cx="640080" cy="640080"/>
-          </a:xfrm>
-          <a:prstGeom prst="ellipse">
-            <a:avLst/>
-          </a:prstGeom>
-          <a:solidFill>
-            <a:srgbClr val="7A8599"/>
-          </a:solidFill>
-          <a:ln>
-            <a:noFill/>
-          </a:ln>
-          <a:effectLst/>
-        </p:spPr>
-        <p:style>
-          <a:lnRef idx="1">
-            <a:schemeClr val="accent1"/>
-          </a:lnRef>
-          <a:fillRef idx="3">
-            <a:schemeClr val="accent1"/>
-          </a:fillRef>
-          <a:effectRef idx="2">
-            <a:schemeClr val="accent1"/>
-          </a:effectRef>
-          <a:fontRef idx="minor">
-            <a:schemeClr val="lt1"/>
-          </a:fontRef>
-        </p:style>
-        <p:txBody>
-          <a:bodyPr rtlCol="0" anchor="ctr"/>
-          <a:lstStyle/>
-          <a:p/>
-        </p:txBody>
-      </p:sp>
-      <p:pic>
-        <p:nvPicPr>
-          <p:cNvPr id="20" name="Picture 19" descr="FaRotate_w.png"/>
-          <p:cNvPicPr>
-            <a:picLocks noChangeAspect="1"/>
-          </p:cNvPicPr>
-          <p:nvPr/>
-        </p:nvPicPr>
-        <p:blipFill>
-          <a:blip r:embed="rId5"/>
-          <a:stretch>
-            <a:fillRect/>
-          </a:stretch>
-        </p:blipFill>
-        <p:spPr>
-          <a:xfrm>
-            <a:off x="891540" y="3863339"/>
-            <a:ext cx="320040" cy="320040"/>
-          </a:xfrm>
-          <a:prstGeom prst="rect">
-            <a:avLst/>
-          </a:prstGeom>
-        </p:spPr>
-      </p:pic>
-      <p:sp>
-        <p:nvSpPr>
-          <p:cNvPr id="21" name="TextBox 20"/>
-          <p:cNvSpPr txBox="1"/>
-          <p:nvPr/>
-        </p:nvSpPr>
-        <p:spPr>
-          <a:xfrm>
-            <a:off x="1508760" y="3657600"/>
-            <a:ext cx="1874519" cy="731520"/>
-          </a:xfrm>
-          <a:prstGeom prst="rect">
-            <a:avLst/>
-          </a:prstGeom>
-          <a:noFill/>
-        </p:spPr>
-        <p:txBody>
-          <a:bodyPr wrap="square" lIns="0" rIns="0" tIns="0" bIns="0" anchor="ctr">
-            <a:spAutoFit/>
-          </a:bodyPr>
-          <a:lstStyle/>
-          <a:p>
-            <a:pPr algn="l"/>
-            <a:r>
-              <a:rPr sz="1500" b="1">
-                <a:solidFill>
-                  <a:srgbClr val="3D4757"/>
-                </a:solidFill>
-                <a:latin typeface="微软雅黑"/>
-                <a:ea typeface="微软雅黑"/>
-                <a:cs typeface="微软雅黑"/>
-              </a:rPr>
-              <a:t>仍走抢票的捡漏扣位</a:t>
-            </a:r>
-          </a:p>
-        </p:txBody>
-      </p:sp>
-      <p:sp>
-        <p:nvSpPr>
-          <p:cNvPr id="22" name="Rounded Rectangle 21"/>
-          <p:cNvSpPr/>
-          <p:nvPr/>
-        </p:nvSpPr>
-        <p:spPr>
-          <a:xfrm>
-            <a:off x="731520" y="4983480"/>
-            <a:ext cx="2514600" cy="640080"/>
-          </a:xfrm>
-          <a:prstGeom prst="roundRect">
-            <a:avLst>
-              <a:gd name="adj" fmla="val 30000"/>
-            </a:avLst>
-          </a:prstGeom>
-          <a:solidFill>
-            <a:srgbClr val="FFFFFF"/>
-          </a:solidFill>
-          <a:ln w="12700">
-            <a:solidFill>
-              <a:srgbClr val="FF7A1A"/>
-            </a:solidFill>
-          </a:ln>
-          <a:effectLst/>
-        </p:spPr>
-        <p:style>
-          <a:lnRef idx="1">
-            <a:schemeClr val="accent1"/>
-          </a:lnRef>
-          <a:fillRef idx="3">
-            <a:schemeClr val="accent1"/>
-          </a:fillRef>
-          <a:effectRef idx="2">
-            <a:schemeClr val="accent1"/>
-          </a:effectRef>
-          <a:fontRef idx="minor">
-            <a:schemeClr val="lt1"/>
-          </a:fontRef>
-        </p:style>
-        <p:txBody>
-          <a:bodyPr rtlCol="0" anchor="ctr"/>
-          <a:lstStyle/>
-          <a:p/>
-        </p:txBody>
-      </p:sp>
-      <p:sp>
-        <p:nvSpPr>
-          <p:cNvPr id="23" name="TextBox 22"/>
-          <p:cNvSpPr txBox="1"/>
-          <p:nvPr/>
-        </p:nvSpPr>
-        <p:spPr>
-          <a:xfrm>
-            <a:off x="731520" y="4983480"/>
-            <a:ext cx="2514600" cy="640080"/>
-          </a:xfrm>
-          <a:prstGeom prst="rect">
-            <a:avLst/>
-          </a:prstGeom>
-          <a:noFill/>
-        </p:spPr>
-        <p:txBody>
-          <a:bodyPr wrap="square" lIns="0" rIns="0" tIns="0" bIns="0" anchor="ctr">
-            <a:spAutoFit/>
-          </a:bodyPr>
-          <a:lstStyle/>
-          <a:p>
-            <a:pPr algn="ctr"/>
-            <a:r>
-              <a:rPr sz="1400" b="1">
-                <a:solidFill>
-                  <a:srgbClr val="FF7A1A"/>
-                </a:solidFill>
-                <a:latin typeface="微软雅黑"/>
-                <a:ea typeface="微软雅黑"/>
-                <a:cs typeface="微软雅黑"/>
-              </a:rPr>
-              <a:t>出票概率【待补充】</a:t>
-            </a:r>
-          </a:p>
-        </p:txBody>
-      </p:sp>
-      <p:sp>
-        <p:nvSpPr>
-          <p:cNvPr id="24" name="Rounded Rectangle 23"/>
-          <p:cNvSpPr/>
-          <p:nvPr/>
-        </p:nvSpPr>
-        <p:spPr>
-          <a:xfrm>
-            <a:off x="3886200" y="2971800"/>
-            <a:ext cx="3063240" cy="3108960"/>
-          </a:xfrm>
-          <a:prstGeom prst="roundRect">
-            <a:avLst>
-              <a:gd name="adj" fmla="val 6000"/>
-            </a:avLst>
-          </a:prstGeom>
-          <a:solidFill>
-            <a:srgbClr val="EAF2FF"/>
-          </a:solidFill>
-          <a:ln w="12700">
-            <a:solidFill>
-              <a:srgbClr val="287DFA"/>
-            </a:solidFill>
-          </a:ln>
-          <a:effectLst/>
-        </p:spPr>
-        <p:style>
-          <a:lnRef idx="1">
-            <a:schemeClr val="accent1"/>
-          </a:lnRef>
-          <a:fillRef idx="3">
-            <a:schemeClr val="accent1"/>
-          </a:fillRef>
-          <a:effectRef idx="2">
-            <a:schemeClr val="accent1"/>
-          </a:effectRef>
-          <a:fontRef idx="minor">
-            <a:schemeClr val="lt1"/>
-          </a:fontRef>
-        </p:style>
-        <p:txBody>
-          <a:bodyPr rtlCol="0" anchor="ctr"/>
-          <a:lstStyle/>
-          <a:p/>
-        </p:txBody>
-      </p:sp>
-      <p:sp>
-        <p:nvSpPr>
-          <p:cNvPr id="25" name="TextBox 24"/>
-          <p:cNvSpPr txBox="1"/>
-          <p:nvPr/>
-        </p:nvSpPr>
-        <p:spPr>
-          <a:xfrm>
-            <a:off x="4160520" y="3127248"/>
-            <a:ext cx="2560320" cy="365760"/>
-          </a:xfrm>
-          <a:prstGeom prst="rect">
-            <a:avLst/>
-          </a:prstGeom>
-          <a:noFill/>
-        </p:spPr>
-        <p:txBody>
-          <a:bodyPr wrap="square" lIns="0" rIns="0" tIns="0" bIns="0" anchor="t">
-            <a:spAutoFit/>
-          </a:bodyPr>
-          <a:lstStyle/>
-          <a:p>
-            <a:pPr algn="l"/>
-            <a:r>
-              <a:rPr sz="1800" b="1">
-                <a:solidFill>
-                  <a:srgbClr val="287DFA"/>
-                </a:solidFill>
-                <a:latin typeface="微软雅黑"/>
-                <a:ea typeface="微软雅黑"/>
-                <a:cs typeface="微软雅黑"/>
-              </a:rPr>
-              <a:t>之后</a:t>
-            </a:r>
-          </a:p>
-        </p:txBody>
-      </p:sp>
-      <p:sp>
-        <p:nvSpPr>
-          <p:cNvPr id="26" name="icon-circle"/>
-          <p:cNvSpPr/>
-          <p:nvPr/>
-        </p:nvSpPr>
-        <p:spPr>
-          <a:xfrm>
-            <a:off x="4160520" y="3703320"/>
-            <a:ext cx="640080" cy="640080"/>
-          </a:xfrm>
-          <a:prstGeom prst="ellipse">
-            <a:avLst/>
-          </a:prstGeom>
-          <a:solidFill>
-            <a:srgbClr val="287DFA"/>
-          </a:solidFill>
-          <a:ln>
-            <a:noFill/>
-          </a:ln>
-          <a:effectLst/>
-        </p:spPr>
-        <p:style>
-          <a:lnRef idx="1">
-            <a:schemeClr val="accent1"/>
-          </a:lnRef>
-          <a:fillRef idx="3">
-            <a:schemeClr val="accent1"/>
-          </a:fillRef>
-          <a:effectRef idx="2">
-            <a:schemeClr val="accent1"/>
-          </a:effectRef>
-          <a:fontRef idx="minor">
-            <a:schemeClr val="lt1"/>
-          </a:fontRef>
-        </p:style>
-        <p:txBody>
-          <a:bodyPr rtlCol="0" anchor="ctr"/>
-          <a:lstStyle/>
-          <a:p/>
-        </p:txBody>
-      </p:sp>
-      <p:pic>
-        <p:nvPicPr>
-          <p:cNvPr id="27" name="Picture 26" descr="FaTicket_w.png"/>
-          <p:cNvPicPr>
-            <a:picLocks noChangeAspect="1"/>
-          </p:cNvPicPr>
-          <p:nvPr/>
-        </p:nvPicPr>
-        <p:blipFill>
-          <a:blip r:embed="rId6"/>
-          <a:stretch>
-            <a:fillRect/>
-          </a:stretch>
-        </p:blipFill>
-        <p:spPr>
-          <a:xfrm>
-            <a:off x="4320540" y="3863339"/>
-            <a:ext cx="320040" cy="320040"/>
-          </a:xfrm>
-          <a:prstGeom prst="rect">
-            <a:avLst/>
-          </a:prstGeom>
-        </p:spPr>
-      </p:pic>
-      <p:sp>
-        <p:nvSpPr>
-          <p:cNvPr id="28" name="TextBox 27"/>
-          <p:cNvSpPr txBox="1"/>
-          <p:nvPr/>
-        </p:nvSpPr>
-        <p:spPr>
-          <a:xfrm>
-            <a:off x="4937760" y="3657600"/>
-            <a:ext cx="1874519" cy="731520"/>
-          </a:xfrm>
-          <a:prstGeom prst="rect">
-            <a:avLst/>
-          </a:prstGeom>
-          <a:noFill/>
-        </p:spPr>
-        <p:txBody>
-          <a:bodyPr wrap="square" lIns="0" rIns="0" tIns="0" bIns="0" anchor="ctr">
-            <a:spAutoFit/>
-          </a:bodyPr>
-          <a:lstStyle/>
-          <a:p>
-            <a:pPr algn="l"/>
-            <a:r>
-              <a:rPr sz="1500" b="1">
-                <a:solidFill>
-                  <a:srgbClr val="3D4757"/>
-                </a:solidFill>
-                <a:latin typeface="微软雅黑"/>
-                <a:ea typeface="微软雅黑"/>
-                <a:cs typeface="微软雅黑"/>
-              </a:rPr>
-              <a:t>直接走买票接口出票</a:t>
-            </a:r>
-          </a:p>
-        </p:txBody>
-      </p:sp>
-      <p:sp>
-        <p:nvSpPr>
-          <p:cNvPr id="29" name="Rounded Rectangle 28"/>
-          <p:cNvSpPr/>
-          <p:nvPr/>
-        </p:nvSpPr>
-        <p:spPr>
-          <a:xfrm>
-            <a:off x="4160520" y="4983480"/>
-            <a:ext cx="2514600" cy="640080"/>
-          </a:xfrm>
-          <a:prstGeom prst="roundRect">
-            <a:avLst>
-              <a:gd name="adj" fmla="val 30000"/>
-            </a:avLst>
-          </a:prstGeom>
-          <a:solidFill>
-            <a:srgbClr val="FFFFFF"/>
-          </a:solidFill>
-          <a:ln w="12700">
-            <a:solidFill>
-              <a:srgbClr val="287DFA"/>
-            </a:solidFill>
-          </a:ln>
-          <a:effectLst/>
-        </p:spPr>
-        <p:style>
-          <a:lnRef idx="1">
-            <a:schemeClr val="accent1"/>
-          </a:lnRef>
-          <a:fillRef idx="3">
-            <a:schemeClr val="accent1"/>
-          </a:fillRef>
-          <a:effectRef idx="2">
-            <a:schemeClr val="accent1"/>
-          </a:effectRef>
-          <a:fontRef idx="minor">
-            <a:schemeClr val="lt1"/>
-          </a:fontRef>
-        </p:style>
-        <p:txBody>
-          <a:bodyPr rtlCol="0" anchor="ctr"/>
-          <a:lstStyle/>
-          <a:p/>
-        </p:txBody>
-      </p:sp>
-      <p:sp>
-        <p:nvSpPr>
-          <p:cNvPr id="30" name="TextBox 29"/>
-          <p:cNvSpPr txBox="1"/>
-          <p:nvPr/>
-        </p:nvSpPr>
-        <p:spPr>
-          <a:xfrm>
-            <a:off x="4160520" y="4983480"/>
-            <a:ext cx="2514600" cy="640080"/>
-          </a:xfrm>
-          <a:prstGeom prst="rect">
-            <a:avLst/>
-          </a:prstGeom>
-          <a:noFill/>
-        </p:spPr>
-        <p:txBody>
-          <a:bodyPr wrap="square" lIns="0" rIns="0" tIns="0" bIns="0" anchor="ctr">
-            <a:spAutoFit/>
-          </a:bodyPr>
-          <a:lstStyle/>
-          <a:p>
-            <a:pPr algn="ctr"/>
-            <a:r>
-              <a:rPr sz="1400" b="1">
-                <a:solidFill>
-                  <a:srgbClr val="287DFA"/>
-                </a:solidFill>
-                <a:latin typeface="微软雅黑"/>
-                <a:ea typeface="微软雅黑"/>
-                <a:cs typeface="微软雅黑"/>
-              </a:rPr>
-              <a:t>上线后增量【待补】</a:t>
-            </a:r>
-          </a:p>
-        </p:txBody>
-      </p:sp>
-      <p:pic>
-        <p:nvPicPr>
-          <p:cNvPr id="31" name="真实截图-抢必走" descr="qbz.png"/>
-          <p:cNvPicPr>
-            <a:picLocks noChangeAspect="1"/>
-          </p:cNvPicPr>
-          <p:nvPr/>
-        </p:nvPicPr>
-        <p:blipFill>
-          <a:blip r:embed="rId7"/>
-          <a:stretch>
-            <a:fillRect/>
-          </a:stretch>
-        </p:blipFill>
-        <p:spPr>
-          <a:xfrm>
-            <a:off x="7721193" y="1481328"/>
+            <a:off x="457200" y="1481328"/>
             <a:ext cx="1913839" cy="4206240"/>
           </a:xfrm>
           <a:prstGeom prst="roundRect">
@@ -6743,13 +5689,13 @@
       </p:pic>
       <p:sp>
         <p:nvSpPr>
-          <p:cNvPr id="32" name="TextBox 31"/>
+          <p:cNvPr id="5" name="TextBox 4"/>
           <p:cNvSpPr txBox="1"/>
           <p:nvPr/>
         </p:nvSpPr>
         <p:spPr>
           <a:xfrm>
-            <a:off x="7721193" y="5760720"/>
+            <a:off x="457200" y="5760720"/>
             <a:ext cx="1913839" cy="274320"/>
           </a:xfrm>
           <a:prstGeom prst="rect">
@@ -6780,21 +5726,21 @@
       </p:sp>
       <p:pic>
         <p:nvPicPr>
-          <p:cNvPr id="33" name="真实截图-有票方案" descr="yoyo.png"/>
+          <p:cNvPr id="6" name="真实截图-有票方案" descr="yoyo.png"/>
           <p:cNvPicPr>
             <a:picLocks noChangeAspect="1"/>
           </p:cNvPicPr>
           <p:nvPr/>
         </p:nvPicPr>
         <p:blipFill>
-          <a:blip r:embed="rId8"/>
+          <a:blip r:embed="rId4"/>
           <a:stretch>
             <a:fillRect/>
           </a:stretch>
         </p:blipFill>
         <p:spPr>
           <a:xfrm>
-            <a:off x="9817912" y="1481328"/>
+            <a:off x="2535631" y="1481328"/>
             <a:ext cx="1913839" cy="4206240"/>
           </a:xfrm>
           <a:prstGeom prst="roundRect">
@@ -6811,13 +5757,13 @@
       </p:pic>
       <p:sp>
         <p:nvSpPr>
-          <p:cNvPr id="34" name="TextBox 33"/>
+          <p:cNvPr id="7" name="TextBox 6"/>
           <p:cNvSpPr txBox="1"/>
           <p:nvPr/>
         </p:nvSpPr>
         <p:spPr>
           <a:xfrm>
-            <a:off x="9817912" y="5760720"/>
+            <a:off x="2535631" y="5760720"/>
             <a:ext cx="1913839" cy="274320"/>
           </a:xfrm>
           <a:prstGeom prst="rect">
@@ -6842,6 +5788,1590 @@
                 <a:cs typeface="微软雅黑"/>
               </a:rPr>
               <a:t>有票方案页</a:t>
+            </a:r>
+          </a:p>
+        </p:txBody>
+      </p:sp>
+      <p:sp>
+        <p:nvSpPr>
+          <p:cNvPr id="8" name="Rounded Rectangle 7"/>
+          <p:cNvSpPr/>
+          <p:nvPr/>
+        </p:nvSpPr>
+        <p:spPr>
+          <a:xfrm>
+            <a:off x="4709160" y="1783080"/>
+            <a:ext cx="1481328" cy="1325880"/>
+          </a:xfrm>
+          <a:prstGeom prst="roundRect">
+            <a:avLst>
+              <a:gd name="adj" fmla="val 6000"/>
+            </a:avLst>
+          </a:prstGeom>
+          <a:solidFill>
+            <a:srgbClr val="F5F9FF"/>
+          </a:solidFill>
+          <a:ln w="12700">
+            <a:solidFill>
+              <a:srgbClr val="D3E2FB"/>
+            </a:solidFill>
+          </a:ln>
+          <a:effectLst/>
+        </p:spPr>
+        <p:style>
+          <a:lnRef idx="1">
+            <a:schemeClr val="accent1"/>
+          </a:lnRef>
+          <a:fillRef idx="3">
+            <a:schemeClr val="accent1"/>
+          </a:fillRef>
+          <a:effectRef idx="2">
+            <a:schemeClr val="accent1"/>
+          </a:effectRef>
+          <a:fontRef idx="minor">
+            <a:schemeClr val="lt1"/>
+          </a:fontRef>
+        </p:style>
+        <p:txBody>
+          <a:bodyPr rtlCol="0" anchor="ctr"/>
+          <a:lstStyle/>
+          <a:p/>
+        </p:txBody>
+      </p:sp>
+      <p:sp>
+        <p:nvSpPr>
+          <p:cNvPr id="9" name="icon-circle"/>
+          <p:cNvSpPr/>
+          <p:nvPr/>
+        </p:nvSpPr>
+        <p:spPr>
+          <a:xfrm>
+            <a:off x="5175504" y="1901952"/>
+            <a:ext cx="548640" cy="548640"/>
+          </a:xfrm>
+          <a:prstGeom prst="ellipse">
+            <a:avLst/>
+          </a:prstGeom>
+          <a:solidFill>
+            <a:srgbClr val="287DFA"/>
+          </a:solidFill>
+          <a:ln>
+            <a:noFill/>
+          </a:ln>
+          <a:effectLst/>
+        </p:spPr>
+        <p:style>
+          <a:lnRef idx="1">
+            <a:schemeClr val="accent1"/>
+          </a:lnRef>
+          <a:fillRef idx="3">
+            <a:schemeClr val="accent1"/>
+          </a:fillRef>
+          <a:effectRef idx="2">
+            <a:schemeClr val="accent1"/>
+          </a:effectRef>
+          <a:fontRef idx="minor">
+            <a:schemeClr val="lt1"/>
+          </a:fontRef>
+        </p:style>
+        <p:txBody>
+          <a:bodyPr rtlCol="0" anchor="ctr"/>
+          <a:lstStyle/>
+          <a:p/>
+        </p:txBody>
+      </p:sp>
+      <p:pic>
+        <p:nvPicPr>
+          <p:cNvPr id="10" name="Picture 9" descr="FaMagnifyingGlass_w.png"/>
+          <p:cNvPicPr>
+            <a:picLocks noChangeAspect="1"/>
+          </p:cNvPicPr>
+          <p:nvPr/>
+        </p:nvPicPr>
+        <p:blipFill>
+          <a:blip r:embed="rId5"/>
+          <a:stretch>
+            <a:fillRect/>
+          </a:stretch>
+        </p:blipFill>
+        <p:spPr>
+          <a:xfrm>
+            <a:off x="5312664" y="2039112"/>
+            <a:ext cx="274320" cy="274320"/>
+          </a:xfrm>
+          <a:prstGeom prst="rect">
+            <a:avLst/>
+          </a:prstGeom>
+        </p:spPr>
+      </p:pic>
+      <p:sp>
+        <p:nvSpPr>
+          <p:cNvPr id="11" name="TextBox 10"/>
+          <p:cNvSpPr txBox="1"/>
+          <p:nvPr/>
+        </p:nvSpPr>
+        <p:spPr>
+          <a:xfrm>
+            <a:off x="4754880" y="2514600"/>
+            <a:ext cx="1389888" cy="548640"/>
+          </a:xfrm>
+          <a:prstGeom prst="rect">
+            <a:avLst/>
+          </a:prstGeom>
+          <a:noFill/>
+        </p:spPr>
+        <p:txBody>
+          <a:bodyPr wrap="square" lIns="0" rIns="0" tIns="0" bIns="0" anchor="t">
+            <a:spAutoFit/>
+          </a:bodyPr>
+          <a:lstStyle/>
+          <a:p>
+            <a:pPr algn="ctr"/>
+            <a:r>
+              <a:rPr sz="1200" b="1">
+                <a:solidFill>
+                  <a:srgbClr val="3D4757"/>
+                </a:solidFill>
+                <a:latin typeface="微软雅黑"/>
+                <a:ea typeface="微软雅黑"/>
+                <a:cs typeface="微软雅黑"/>
+              </a:rPr>
+              <a:t>抢票中</a:t>
+            </a:r>
+          </a:p>
+          <a:p>
+            <a:pPr algn="ctr">
+              <a:spcBef>
+                <a:spcPts val="0"/>
+              </a:spcBef>
+            </a:pPr>
+            <a:r>
+              <a:rPr sz="1200" b="1">
+                <a:solidFill>
+                  <a:srgbClr val="3D4757"/>
+                </a:solidFill>
+                <a:latin typeface="微软雅黑"/>
+                <a:ea typeface="微软雅黑"/>
+                <a:cs typeface="微软雅黑"/>
+              </a:rPr>
+              <a:t>持续监控余票</a:t>
+            </a:r>
+          </a:p>
+        </p:txBody>
+      </p:sp>
+      <p:sp>
+        <p:nvSpPr>
+          <p:cNvPr id="12" name="arrow"/>
+          <p:cNvSpPr/>
+          <p:nvPr/>
+        </p:nvSpPr>
+        <p:spPr>
+          <a:xfrm>
+            <a:off x="6245352" y="2331720"/>
+            <a:ext cx="219456" cy="237744"/>
+          </a:xfrm>
+          <a:prstGeom prst="rightArrow">
+            <a:avLst/>
+          </a:prstGeom>
+          <a:solidFill>
+            <a:srgbClr val="D3E2FB"/>
+          </a:solidFill>
+          <a:ln>
+            <a:noFill/>
+          </a:ln>
+          <a:effectLst/>
+        </p:spPr>
+        <p:style>
+          <a:lnRef idx="1">
+            <a:schemeClr val="accent1"/>
+          </a:lnRef>
+          <a:fillRef idx="3">
+            <a:schemeClr val="accent1"/>
+          </a:fillRef>
+          <a:effectRef idx="2">
+            <a:schemeClr val="accent1"/>
+          </a:effectRef>
+          <a:fontRef idx="minor">
+            <a:schemeClr val="lt1"/>
+          </a:fontRef>
+        </p:style>
+        <p:txBody>
+          <a:bodyPr rtlCol="0" anchor="ctr"/>
+          <a:lstStyle/>
+          <a:p/>
+        </p:txBody>
+      </p:sp>
+      <p:sp>
+        <p:nvSpPr>
+          <p:cNvPr id="13" name="TextBox 12"/>
+          <p:cNvSpPr txBox="1"/>
+          <p:nvPr/>
+        </p:nvSpPr>
+        <p:spPr>
+          <a:xfrm>
+            <a:off x="4709160" y="1481328"/>
+            <a:ext cx="1481328" cy="274320"/>
+          </a:xfrm>
+          <a:prstGeom prst="rect">
+            <a:avLst/>
+          </a:prstGeom>
+          <a:noFill/>
+        </p:spPr>
+        <p:txBody>
+          <a:bodyPr wrap="square" lIns="0" rIns="0" tIns="0" bIns="0" anchor="t">
+            <a:spAutoFit/>
+          </a:bodyPr>
+          <a:lstStyle/>
+          <a:p>
+            <a:pPr algn="ctr"/>
+            <a:r>
+              <a:rPr sz="1100" b="1">
+                <a:solidFill>
+                  <a:srgbClr val="7A8599"/>
+                </a:solidFill>
+                <a:latin typeface="微软雅黑"/>
+                <a:ea typeface="微软雅黑"/>
+                <a:cs typeface="微软雅黑"/>
+              </a:rPr>
+              <a:t>第 1 步</a:t>
+            </a:r>
+          </a:p>
+        </p:txBody>
+      </p:sp>
+      <p:sp>
+        <p:nvSpPr>
+          <p:cNvPr id="14" name="Rounded Rectangle 13"/>
+          <p:cNvSpPr/>
+          <p:nvPr/>
+        </p:nvSpPr>
+        <p:spPr>
+          <a:xfrm>
+            <a:off x="6519672" y="1783080"/>
+            <a:ext cx="1481328" cy="1325880"/>
+          </a:xfrm>
+          <a:prstGeom prst="roundRect">
+            <a:avLst>
+              <a:gd name="adj" fmla="val 6000"/>
+            </a:avLst>
+          </a:prstGeom>
+          <a:solidFill>
+            <a:srgbClr val="F5F9FF"/>
+          </a:solidFill>
+          <a:ln w="12700">
+            <a:solidFill>
+              <a:srgbClr val="D3E2FB"/>
+            </a:solidFill>
+          </a:ln>
+          <a:effectLst/>
+        </p:spPr>
+        <p:style>
+          <a:lnRef idx="1">
+            <a:schemeClr val="accent1"/>
+          </a:lnRef>
+          <a:fillRef idx="3">
+            <a:schemeClr val="accent1"/>
+          </a:fillRef>
+          <a:effectRef idx="2">
+            <a:schemeClr val="accent1"/>
+          </a:effectRef>
+          <a:fontRef idx="minor">
+            <a:schemeClr val="lt1"/>
+          </a:fontRef>
+        </p:style>
+        <p:txBody>
+          <a:bodyPr rtlCol="0" anchor="ctr"/>
+          <a:lstStyle/>
+          <a:p/>
+        </p:txBody>
+      </p:sp>
+      <p:sp>
+        <p:nvSpPr>
+          <p:cNvPr id="15" name="icon-circle"/>
+          <p:cNvSpPr/>
+          <p:nvPr/>
+        </p:nvSpPr>
+        <p:spPr>
+          <a:xfrm>
+            <a:off x="6986016" y="1901952"/>
+            <a:ext cx="548640" cy="548640"/>
+          </a:xfrm>
+          <a:prstGeom prst="ellipse">
+            <a:avLst/>
+          </a:prstGeom>
+          <a:solidFill>
+            <a:srgbClr val="287DFA"/>
+          </a:solidFill>
+          <a:ln>
+            <a:noFill/>
+          </a:ln>
+          <a:effectLst/>
+        </p:spPr>
+        <p:style>
+          <a:lnRef idx="1">
+            <a:schemeClr val="accent1"/>
+          </a:lnRef>
+          <a:fillRef idx="3">
+            <a:schemeClr val="accent1"/>
+          </a:fillRef>
+          <a:effectRef idx="2">
+            <a:schemeClr val="accent1"/>
+          </a:effectRef>
+          <a:fontRef idx="minor">
+            <a:schemeClr val="lt1"/>
+          </a:fontRef>
+        </p:style>
+        <p:txBody>
+          <a:bodyPr rtlCol="0" anchor="ctr"/>
+          <a:lstStyle/>
+          <a:p/>
+        </p:txBody>
+      </p:sp>
+      <p:pic>
+        <p:nvPicPr>
+          <p:cNvPr id="16" name="Picture 15" descr="FaListCheck_w.png"/>
+          <p:cNvPicPr>
+            <a:picLocks noChangeAspect="1"/>
+          </p:cNvPicPr>
+          <p:nvPr/>
+        </p:nvPicPr>
+        <p:blipFill>
+          <a:blip r:embed="rId6"/>
+          <a:stretch>
+            <a:fillRect/>
+          </a:stretch>
+        </p:blipFill>
+        <p:spPr>
+          <a:xfrm>
+            <a:off x="7123176" y="2039112"/>
+            <a:ext cx="274320" cy="274320"/>
+          </a:xfrm>
+          <a:prstGeom prst="rect">
+            <a:avLst/>
+          </a:prstGeom>
+        </p:spPr>
+      </p:pic>
+      <p:sp>
+        <p:nvSpPr>
+          <p:cNvPr id="17" name="TextBox 16"/>
+          <p:cNvSpPr txBox="1"/>
+          <p:nvPr/>
+        </p:nvSpPr>
+        <p:spPr>
+          <a:xfrm>
+            <a:off x="6565392" y="2514600"/>
+            <a:ext cx="1389888" cy="548640"/>
+          </a:xfrm>
+          <a:prstGeom prst="rect">
+            <a:avLst/>
+          </a:prstGeom>
+          <a:noFill/>
+        </p:spPr>
+        <p:txBody>
+          <a:bodyPr wrap="square" lIns="0" rIns="0" tIns="0" bIns="0" anchor="t">
+            <a:spAutoFit/>
+          </a:bodyPr>
+          <a:lstStyle/>
+          <a:p>
+            <a:pPr algn="ctr"/>
+            <a:r>
+              <a:rPr sz="1200" b="1">
+                <a:solidFill>
+                  <a:srgbClr val="3D4757"/>
+                </a:solidFill>
+                <a:latin typeface="微软雅黑"/>
+                <a:ea typeface="微软雅黑"/>
+                <a:cs typeface="微软雅黑"/>
+              </a:rPr>
+              <a:t>推荐可立即</a:t>
+            </a:r>
+          </a:p>
+          <a:p>
+            <a:pPr algn="ctr">
+              <a:spcBef>
+                <a:spcPts val="0"/>
+              </a:spcBef>
+            </a:pPr>
+            <a:r>
+              <a:rPr sz="1200" b="1">
+                <a:solidFill>
+                  <a:srgbClr val="3D4757"/>
+                </a:solidFill>
+                <a:latin typeface="微软雅黑"/>
+                <a:ea typeface="微软雅黑"/>
+                <a:cs typeface="微软雅黑"/>
+              </a:rPr>
+              <a:t>出票的替代方案</a:t>
+            </a:r>
+          </a:p>
+        </p:txBody>
+      </p:sp>
+      <p:sp>
+        <p:nvSpPr>
+          <p:cNvPr id="18" name="arrow"/>
+          <p:cNvSpPr/>
+          <p:nvPr/>
+        </p:nvSpPr>
+        <p:spPr>
+          <a:xfrm>
+            <a:off x="8055864" y="2331720"/>
+            <a:ext cx="219456" cy="237744"/>
+          </a:xfrm>
+          <a:prstGeom prst="rightArrow">
+            <a:avLst/>
+          </a:prstGeom>
+          <a:solidFill>
+            <a:srgbClr val="D3E2FB"/>
+          </a:solidFill>
+          <a:ln>
+            <a:noFill/>
+          </a:ln>
+          <a:effectLst/>
+        </p:spPr>
+        <p:style>
+          <a:lnRef idx="1">
+            <a:schemeClr val="accent1"/>
+          </a:lnRef>
+          <a:fillRef idx="3">
+            <a:schemeClr val="accent1"/>
+          </a:fillRef>
+          <a:effectRef idx="2">
+            <a:schemeClr val="accent1"/>
+          </a:effectRef>
+          <a:fontRef idx="minor">
+            <a:schemeClr val="lt1"/>
+          </a:fontRef>
+        </p:style>
+        <p:txBody>
+          <a:bodyPr rtlCol="0" anchor="ctr"/>
+          <a:lstStyle/>
+          <a:p/>
+        </p:txBody>
+      </p:sp>
+      <p:sp>
+        <p:nvSpPr>
+          <p:cNvPr id="19" name="TextBox 18"/>
+          <p:cNvSpPr txBox="1"/>
+          <p:nvPr/>
+        </p:nvSpPr>
+        <p:spPr>
+          <a:xfrm>
+            <a:off x="6519672" y="1481328"/>
+            <a:ext cx="1481328" cy="274320"/>
+          </a:xfrm>
+          <a:prstGeom prst="rect">
+            <a:avLst/>
+          </a:prstGeom>
+          <a:noFill/>
+        </p:spPr>
+        <p:txBody>
+          <a:bodyPr wrap="square" lIns="0" rIns="0" tIns="0" bIns="0" anchor="t">
+            <a:spAutoFit/>
+          </a:bodyPr>
+          <a:lstStyle/>
+          <a:p>
+            <a:pPr algn="ctr"/>
+            <a:r>
+              <a:rPr sz="1100" b="1">
+                <a:solidFill>
+                  <a:srgbClr val="7A8599"/>
+                </a:solidFill>
+                <a:latin typeface="微软雅黑"/>
+                <a:ea typeface="微软雅黑"/>
+                <a:cs typeface="微软雅黑"/>
+              </a:rPr>
+              <a:t>第 2 步</a:t>
+            </a:r>
+          </a:p>
+        </p:txBody>
+      </p:sp>
+      <p:sp>
+        <p:nvSpPr>
+          <p:cNvPr id="20" name="Rounded Rectangle 19"/>
+          <p:cNvSpPr/>
+          <p:nvPr/>
+        </p:nvSpPr>
+        <p:spPr>
+          <a:xfrm>
+            <a:off x="8330183" y="1783080"/>
+            <a:ext cx="1481328" cy="1325880"/>
+          </a:xfrm>
+          <a:prstGeom prst="roundRect">
+            <a:avLst>
+              <a:gd name="adj" fmla="val 6000"/>
+            </a:avLst>
+          </a:prstGeom>
+          <a:solidFill>
+            <a:srgbClr val="F5F9FF"/>
+          </a:solidFill>
+          <a:ln w="12700">
+            <a:solidFill>
+              <a:srgbClr val="D3E2FB"/>
+            </a:solidFill>
+          </a:ln>
+          <a:effectLst/>
+        </p:spPr>
+        <p:style>
+          <a:lnRef idx="1">
+            <a:schemeClr val="accent1"/>
+          </a:lnRef>
+          <a:fillRef idx="3">
+            <a:schemeClr val="accent1"/>
+          </a:fillRef>
+          <a:effectRef idx="2">
+            <a:schemeClr val="accent1"/>
+          </a:effectRef>
+          <a:fontRef idx="minor">
+            <a:schemeClr val="lt1"/>
+          </a:fontRef>
+        </p:style>
+        <p:txBody>
+          <a:bodyPr rtlCol="0" anchor="ctr"/>
+          <a:lstStyle/>
+          <a:p/>
+        </p:txBody>
+      </p:sp>
+      <p:sp>
+        <p:nvSpPr>
+          <p:cNvPr id="21" name="icon-circle"/>
+          <p:cNvSpPr/>
+          <p:nvPr/>
+        </p:nvSpPr>
+        <p:spPr>
+          <a:xfrm>
+            <a:off x="8796528" y="1901952"/>
+            <a:ext cx="548640" cy="548640"/>
+          </a:xfrm>
+          <a:prstGeom prst="ellipse">
+            <a:avLst/>
+          </a:prstGeom>
+          <a:solidFill>
+            <a:srgbClr val="287DFA"/>
+          </a:solidFill>
+          <a:ln>
+            <a:noFill/>
+          </a:ln>
+          <a:effectLst/>
+        </p:spPr>
+        <p:style>
+          <a:lnRef idx="1">
+            <a:schemeClr val="accent1"/>
+          </a:lnRef>
+          <a:fillRef idx="3">
+            <a:schemeClr val="accent1"/>
+          </a:fillRef>
+          <a:effectRef idx="2">
+            <a:schemeClr val="accent1"/>
+          </a:effectRef>
+          <a:fontRef idx="minor">
+            <a:schemeClr val="lt1"/>
+          </a:fontRef>
+        </p:style>
+        <p:txBody>
+          <a:bodyPr rtlCol="0" anchor="ctr"/>
+          <a:lstStyle/>
+          <a:p/>
+        </p:txBody>
+      </p:sp>
+      <p:pic>
+        <p:nvPicPr>
+          <p:cNvPr id="22" name="Picture 21" descr="FaUserCheck_w.png"/>
+          <p:cNvPicPr>
+            <a:picLocks noChangeAspect="1"/>
+          </p:cNvPicPr>
+          <p:nvPr/>
+        </p:nvPicPr>
+        <p:blipFill>
+          <a:blip r:embed="rId7"/>
+          <a:stretch>
+            <a:fillRect/>
+          </a:stretch>
+        </p:blipFill>
+        <p:spPr>
+          <a:xfrm>
+            <a:off x="8933688" y="2039112"/>
+            <a:ext cx="274320" cy="274320"/>
+          </a:xfrm>
+          <a:prstGeom prst="rect">
+            <a:avLst/>
+          </a:prstGeom>
+        </p:spPr>
+      </p:pic>
+      <p:sp>
+        <p:nvSpPr>
+          <p:cNvPr id="23" name="TextBox 22"/>
+          <p:cNvSpPr txBox="1"/>
+          <p:nvPr/>
+        </p:nvSpPr>
+        <p:spPr>
+          <a:xfrm>
+            <a:off x="8375904" y="2514600"/>
+            <a:ext cx="1389888" cy="548640"/>
+          </a:xfrm>
+          <a:prstGeom prst="rect">
+            <a:avLst/>
+          </a:prstGeom>
+          <a:noFill/>
+        </p:spPr>
+        <p:txBody>
+          <a:bodyPr wrap="square" lIns="0" rIns="0" tIns="0" bIns="0" anchor="t">
+            <a:spAutoFit/>
+          </a:bodyPr>
+          <a:lstStyle/>
+          <a:p>
+            <a:pPr algn="ctr"/>
+            <a:r>
+              <a:rPr sz="1200" b="1">
+                <a:solidFill>
+                  <a:srgbClr val="3D4757"/>
+                </a:solidFill>
+                <a:latin typeface="微软雅黑"/>
+                <a:ea typeface="微软雅黑"/>
+                <a:cs typeface="微软雅黑"/>
+              </a:rPr>
+              <a:t>用户让步</a:t>
+            </a:r>
+          </a:p>
+          <a:p>
+            <a:pPr algn="ctr">
+              <a:spcBef>
+                <a:spcPts val="0"/>
+              </a:spcBef>
+            </a:pPr>
+            <a:r>
+              <a:rPr sz="1200" b="1">
+                <a:solidFill>
+                  <a:srgbClr val="3D4757"/>
+                </a:solidFill>
+                <a:latin typeface="微软雅黑"/>
+                <a:ea typeface="微软雅黑"/>
+                <a:cs typeface="微软雅黑"/>
+              </a:rPr>
+              <a:t>接受替代方案</a:t>
+            </a:r>
+          </a:p>
+        </p:txBody>
+      </p:sp>
+      <p:sp>
+        <p:nvSpPr>
+          <p:cNvPr id="24" name="arrow"/>
+          <p:cNvSpPr/>
+          <p:nvPr/>
+        </p:nvSpPr>
+        <p:spPr>
+          <a:xfrm>
+            <a:off x="9866376" y="2331720"/>
+            <a:ext cx="219456" cy="237744"/>
+          </a:xfrm>
+          <a:prstGeom prst="rightArrow">
+            <a:avLst/>
+          </a:prstGeom>
+          <a:solidFill>
+            <a:srgbClr val="D3E2FB"/>
+          </a:solidFill>
+          <a:ln>
+            <a:noFill/>
+          </a:ln>
+          <a:effectLst/>
+        </p:spPr>
+        <p:style>
+          <a:lnRef idx="1">
+            <a:schemeClr val="accent1"/>
+          </a:lnRef>
+          <a:fillRef idx="3">
+            <a:schemeClr val="accent1"/>
+          </a:fillRef>
+          <a:effectRef idx="2">
+            <a:schemeClr val="accent1"/>
+          </a:effectRef>
+          <a:fontRef idx="minor">
+            <a:schemeClr val="lt1"/>
+          </a:fontRef>
+        </p:style>
+        <p:txBody>
+          <a:bodyPr rtlCol="0" anchor="ctr"/>
+          <a:lstStyle/>
+          <a:p/>
+        </p:txBody>
+      </p:sp>
+      <p:sp>
+        <p:nvSpPr>
+          <p:cNvPr id="25" name="TextBox 24"/>
+          <p:cNvSpPr txBox="1"/>
+          <p:nvPr/>
+        </p:nvSpPr>
+        <p:spPr>
+          <a:xfrm>
+            <a:off x="8330183" y="1481328"/>
+            <a:ext cx="1481328" cy="274320"/>
+          </a:xfrm>
+          <a:prstGeom prst="rect">
+            <a:avLst/>
+          </a:prstGeom>
+          <a:noFill/>
+        </p:spPr>
+        <p:txBody>
+          <a:bodyPr wrap="square" lIns="0" rIns="0" tIns="0" bIns="0" anchor="t">
+            <a:spAutoFit/>
+          </a:bodyPr>
+          <a:lstStyle/>
+          <a:p>
+            <a:pPr algn="ctr"/>
+            <a:r>
+              <a:rPr sz="1100" b="1">
+                <a:solidFill>
+                  <a:srgbClr val="7A8599"/>
+                </a:solidFill>
+                <a:latin typeface="微软雅黑"/>
+                <a:ea typeface="微软雅黑"/>
+                <a:cs typeface="微软雅黑"/>
+              </a:rPr>
+              <a:t>第 3 步</a:t>
+            </a:r>
+          </a:p>
+        </p:txBody>
+      </p:sp>
+      <p:sp>
+        <p:nvSpPr>
+          <p:cNvPr id="26" name="Rounded Rectangle 25"/>
+          <p:cNvSpPr/>
+          <p:nvPr/>
+        </p:nvSpPr>
+        <p:spPr>
+          <a:xfrm>
+            <a:off x="10140696" y="1783080"/>
+            <a:ext cx="1481328" cy="1325880"/>
+          </a:xfrm>
+          <a:prstGeom prst="roundRect">
+            <a:avLst>
+              <a:gd name="adj" fmla="val 6000"/>
+            </a:avLst>
+          </a:prstGeom>
+          <a:solidFill>
+            <a:srgbClr val="FFF3EA"/>
+          </a:solidFill>
+          <a:ln w="12700">
+            <a:solidFill>
+              <a:srgbClr val="FF7A1A"/>
+            </a:solidFill>
+          </a:ln>
+          <a:effectLst/>
+        </p:spPr>
+        <p:style>
+          <a:lnRef idx="1">
+            <a:schemeClr val="accent1"/>
+          </a:lnRef>
+          <a:fillRef idx="3">
+            <a:schemeClr val="accent1"/>
+          </a:fillRef>
+          <a:effectRef idx="2">
+            <a:schemeClr val="accent1"/>
+          </a:effectRef>
+          <a:fontRef idx="minor">
+            <a:schemeClr val="lt1"/>
+          </a:fontRef>
+        </p:style>
+        <p:txBody>
+          <a:bodyPr rtlCol="0" anchor="ctr"/>
+          <a:lstStyle/>
+          <a:p/>
+        </p:txBody>
+      </p:sp>
+      <p:sp>
+        <p:nvSpPr>
+          <p:cNvPr id="27" name="icon-circle"/>
+          <p:cNvSpPr/>
+          <p:nvPr/>
+        </p:nvSpPr>
+        <p:spPr>
+          <a:xfrm>
+            <a:off x="10607040" y="1901952"/>
+            <a:ext cx="548640" cy="548640"/>
+          </a:xfrm>
+          <a:prstGeom prst="ellipse">
+            <a:avLst/>
+          </a:prstGeom>
+          <a:solidFill>
+            <a:srgbClr val="FF7A1A"/>
+          </a:solidFill>
+          <a:ln>
+            <a:noFill/>
+          </a:ln>
+          <a:effectLst/>
+        </p:spPr>
+        <p:style>
+          <a:lnRef idx="1">
+            <a:schemeClr val="accent1"/>
+          </a:lnRef>
+          <a:fillRef idx="3">
+            <a:schemeClr val="accent1"/>
+          </a:fillRef>
+          <a:effectRef idx="2">
+            <a:schemeClr val="accent1"/>
+          </a:effectRef>
+          <a:fontRef idx="minor">
+            <a:schemeClr val="lt1"/>
+          </a:fontRef>
+        </p:style>
+        <p:txBody>
+          <a:bodyPr rtlCol="0" anchor="ctr"/>
+          <a:lstStyle/>
+          <a:p/>
+        </p:txBody>
+      </p:sp>
+      <p:pic>
+        <p:nvPicPr>
+          <p:cNvPr id="28" name="Picture 27" descr="FaTicket_w.png"/>
+          <p:cNvPicPr>
+            <a:picLocks noChangeAspect="1"/>
+          </p:cNvPicPr>
+          <p:nvPr/>
+        </p:nvPicPr>
+        <p:blipFill>
+          <a:blip r:embed="rId8"/>
+          <a:stretch>
+            <a:fillRect/>
+          </a:stretch>
+        </p:blipFill>
+        <p:spPr>
+          <a:xfrm>
+            <a:off x="10744200" y="2039112"/>
+            <a:ext cx="274320" cy="274320"/>
+          </a:xfrm>
+          <a:prstGeom prst="rect">
+            <a:avLst/>
+          </a:prstGeom>
+        </p:spPr>
+      </p:pic>
+      <p:sp>
+        <p:nvSpPr>
+          <p:cNvPr id="29" name="TextBox 28"/>
+          <p:cNvSpPr txBox="1"/>
+          <p:nvPr/>
+        </p:nvSpPr>
+        <p:spPr>
+          <a:xfrm>
+            <a:off x="10186416" y="2514600"/>
+            <a:ext cx="1389888" cy="548640"/>
+          </a:xfrm>
+          <a:prstGeom prst="rect">
+            <a:avLst/>
+          </a:prstGeom>
+          <a:noFill/>
+        </p:spPr>
+        <p:txBody>
+          <a:bodyPr wrap="square" lIns="0" rIns="0" tIns="0" bIns="0" anchor="t">
+            <a:spAutoFit/>
+          </a:bodyPr>
+          <a:lstStyle/>
+          <a:p>
+            <a:pPr algn="ctr"/>
+            <a:r>
+              <a:rPr sz="1200" b="1">
+                <a:solidFill>
+                  <a:srgbClr val="3D4757"/>
+                </a:solidFill>
+                <a:latin typeface="微软雅黑"/>
+                <a:ea typeface="微软雅黑"/>
+                <a:cs typeface="微软雅黑"/>
+              </a:rPr>
+              <a:t>出票</a:t>
+            </a:r>
+          </a:p>
+        </p:txBody>
+      </p:sp>
+      <p:sp>
+        <p:nvSpPr>
+          <p:cNvPr id="30" name="TextBox 29"/>
+          <p:cNvSpPr txBox="1"/>
+          <p:nvPr/>
+        </p:nvSpPr>
+        <p:spPr>
+          <a:xfrm>
+            <a:off x="10140696" y="1481328"/>
+            <a:ext cx="1481328" cy="274320"/>
+          </a:xfrm>
+          <a:prstGeom prst="rect">
+            <a:avLst/>
+          </a:prstGeom>
+          <a:noFill/>
+        </p:spPr>
+        <p:txBody>
+          <a:bodyPr wrap="square" lIns="0" rIns="0" tIns="0" bIns="0" anchor="t">
+            <a:spAutoFit/>
+          </a:bodyPr>
+          <a:lstStyle/>
+          <a:p>
+            <a:pPr algn="ctr"/>
+            <a:r>
+              <a:rPr sz="1100" b="1">
+                <a:solidFill>
+                  <a:srgbClr val="FF7A1A"/>
+                </a:solidFill>
+                <a:latin typeface="微软雅黑"/>
+                <a:ea typeface="微软雅黑"/>
+                <a:cs typeface="微软雅黑"/>
+              </a:rPr>
+              <a:t>第 4 步</a:t>
+            </a:r>
+          </a:p>
+        </p:txBody>
+      </p:sp>
+      <p:sp>
+        <p:nvSpPr>
+          <p:cNvPr id="31" name="Rounded Rectangle 30"/>
+          <p:cNvSpPr/>
+          <p:nvPr/>
+        </p:nvSpPr>
+        <p:spPr>
+          <a:xfrm>
+            <a:off x="10369296" y="3200400"/>
+            <a:ext cx="1024128" cy="274320"/>
+          </a:xfrm>
+          <a:prstGeom prst="roundRect">
+            <a:avLst>
+              <a:gd name="adj" fmla="val 50000"/>
+            </a:avLst>
+          </a:prstGeom>
+          <a:solidFill>
+            <a:srgbClr val="FF7A1A"/>
+          </a:solidFill>
+          <a:ln>
+            <a:noFill/>
+          </a:ln>
+          <a:effectLst/>
+        </p:spPr>
+        <p:style>
+          <a:lnRef idx="1">
+            <a:schemeClr val="accent1"/>
+          </a:lnRef>
+          <a:fillRef idx="3">
+            <a:schemeClr val="accent1"/>
+          </a:fillRef>
+          <a:effectRef idx="2">
+            <a:schemeClr val="accent1"/>
+          </a:effectRef>
+          <a:fontRef idx="minor">
+            <a:schemeClr val="lt1"/>
+          </a:fontRef>
+        </p:style>
+        <p:txBody>
+          <a:bodyPr rtlCol="0" anchor="ctr"/>
+          <a:lstStyle/>
+          <a:p/>
+        </p:txBody>
+      </p:sp>
+      <p:sp>
+        <p:nvSpPr>
+          <p:cNvPr id="32" name="TextBox 31"/>
+          <p:cNvSpPr txBox="1"/>
+          <p:nvPr/>
+        </p:nvSpPr>
+        <p:spPr>
+          <a:xfrm>
+            <a:off x="10369296" y="3200400"/>
+            <a:ext cx="1024128" cy="274320"/>
+          </a:xfrm>
+          <a:prstGeom prst="rect">
+            <a:avLst/>
+          </a:prstGeom>
+          <a:noFill/>
+        </p:spPr>
+        <p:txBody>
+          <a:bodyPr wrap="square" lIns="0" rIns="0" tIns="0" bIns="0" anchor="ctr">
+            <a:spAutoFit/>
+          </a:bodyPr>
+          <a:lstStyle/>
+          <a:p>
+            <a:pPr algn="ctr"/>
+            <a:r>
+              <a:rPr sz="1100" b="1">
+                <a:solidFill>
+                  <a:srgbClr val="FFFFFF"/>
+                </a:solidFill>
+                <a:latin typeface="微软雅黑"/>
+                <a:ea typeface="微软雅黑"/>
+                <a:cs typeface="微软雅黑"/>
+              </a:rPr>
+              <a:t>需要修改</a:t>
+            </a:r>
+          </a:p>
+        </p:txBody>
+      </p:sp>
+      <p:sp>
+        <p:nvSpPr>
+          <p:cNvPr id="33" name="TextBox 32"/>
+          <p:cNvSpPr txBox="1"/>
+          <p:nvPr/>
+        </p:nvSpPr>
+        <p:spPr>
+          <a:xfrm>
+            <a:off x="4709160" y="3611880"/>
+            <a:ext cx="6949440" cy="320040"/>
+          </a:xfrm>
+          <a:prstGeom prst="rect">
+            <a:avLst/>
+          </a:prstGeom>
+          <a:noFill/>
+        </p:spPr>
+        <p:txBody>
+          <a:bodyPr wrap="square" lIns="0" rIns="0" tIns="0" bIns="0" anchor="t">
+            <a:spAutoFit/>
+          </a:bodyPr>
+          <a:lstStyle/>
+          <a:p>
+            <a:pPr algn="l"/>
+            <a:r>
+              <a:rPr sz="1400" b="1">
+                <a:solidFill>
+                  <a:srgbClr val="15315E"/>
+                </a:solidFill>
+                <a:latin typeface="微软雅黑"/>
+                <a:ea typeface="微软雅黑"/>
+                <a:cs typeface="微软雅黑"/>
+              </a:rPr>
+              <a:t>第 4 步怎么走</a:t>
+            </a:r>
+          </a:p>
+        </p:txBody>
+      </p:sp>
+      <p:sp>
+        <p:nvSpPr>
+          <p:cNvPr id="34" name="Rounded Rectangle 33"/>
+          <p:cNvSpPr/>
+          <p:nvPr/>
+        </p:nvSpPr>
+        <p:spPr>
+          <a:xfrm>
+            <a:off x="4709160" y="4069080"/>
+            <a:ext cx="777240" cy="731520"/>
+          </a:xfrm>
+          <a:prstGeom prst="roundRect">
+            <a:avLst>
+              <a:gd name="adj" fmla="val 20000"/>
+            </a:avLst>
+          </a:prstGeom>
+          <a:solidFill>
+            <a:srgbClr val="7A8599"/>
+          </a:solidFill>
+          <a:ln>
+            <a:noFill/>
+          </a:ln>
+          <a:effectLst/>
+        </p:spPr>
+        <p:style>
+          <a:lnRef idx="1">
+            <a:schemeClr val="accent1"/>
+          </a:lnRef>
+          <a:fillRef idx="3">
+            <a:schemeClr val="accent1"/>
+          </a:fillRef>
+          <a:effectRef idx="2">
+            <a:schemeClr val="accent1"/>
+          </a:effectRef>
+          <a:fontRef idx="minor">
+            <a:schemeClr val="lt1"/>
+          </a:fontRef>
+        </p:style>
+        <p:txBody>
+          <a:bodyPr rtlCol="0" anchor="ctr"/>
+          <a:lstStyle/>
+          <a:p/>
+        </p:txBody>
+      </p:sp>
+      <p:sp>
+        <p:nvSpPr>
+          <p:cNvPr id="35" name="TextBox 34"/>
+          <p:cNvSpPr txBox="1"/>
+          <p:nvPr/>
+        </p:nvSpPr>
+        <p:spPr>
+          <a:xfrm>
+            <a:off x="4709160" y="4069080"/>
+            <a:ext cx="777240" cy="731520"/>
+          </a:xfrm>
+          <a:prstGeom prst="rect">
+            <a:avLst/>
+          </a:prstGeom>
+          <a:noFill/>
+        </p:spPr>
+        <p:txBody>
+          <a:bodyPr wrap="square" lIns="0" rIns="0" tIns="0" bIns="0" anchor="ctr">
+            <a:spAutoFit/>
+          </a:bodyPr>
+          <a:lstStyle/>
+          <a:p>
+            <a:pPr algn="ctr"/>
+            <a:r>
+              <a:rPr sz="1400" b="1">
+                <a:solidFill>
+                  <a:srgbClr val="FFFFFF"/>
+                </a:solidFill>
+                <a:latin typeface="微软雅黑"/>
+                <a:ea typeface="微软雅黑"/>
+                <a:cs typeface="微软雅黑"/>
+              </a:rPr>
+              <a:t>之前</a:t>
+            </a:r>
+          </a:p>
+        </p:txBody>
+      </p:sp>
+      <p:sp>
+        <p:nvSpPr>
+          <p:cNvPr id="36" name="Rounded Rectangle 35"/>
+          <p:cNvSpPr/>
+          <p:nvPr/>
+        </p:nvSpPr>
+        <p:spPr>
+          <a:xfrm>
+            <a:off x="5605272" y="4069080"/>
+            <a:ext cx="6053328" cy="731520"/>
+          </a:xfrm>
+          <a:prstGeom prst="roundRect">
+            <a:avLst>
+              <a:gd name="adj" fmla="val 6000"/>
+            </a:avLst>
+          </a:prstGeom>
+          <a:solidFill>
+            <a:srgbClr val="FFF3EA"/>
+          </a:solidFill>
+          <a:ln w="12700">
+            <a:solidFill>
+              <a:srgbClr val="FF7A1A"/>
+            </a:solidFill>
+          </a:ln>
+          <a:effectLst/>
+        </p:spPr>
+        <p:style>
+          <a:lnRef idx="1">
+            <a:schemeClr val="accent1"/>
+          </a:lnRef>
+          <a:fillRef idx="3">
+            <a:schemeClr val="accent1"/>
+          </a:fillRef>
+          <a:effectRef idx="2">
+            <a:schemeClr val="accent1"/>
+          </a:effectRef>
+          <a:fontRef idx="minor">
+            <a:schemeClr val="lt1"/>
+          </a:fontRef>
+        </p:style>
+        <p:txBody>
+          <a:bodyPr rtlCol="0" anchor="ctr"/>
+          <a:lstStyle/>
+          <a:p/>
+        </p:txBody>
+      </p:sp>
+      <p:pic>
+        <p:nvPicPr>
+          <p:cNvPr id="37" name="Picture 36" descr="FaRotate_o.png"/>
+          <p:cNvPicPr>
+            <a:picLocks noChangeAspect="1"/>
+          </p:cNvPicPr>
+          <p:nvPr/>
+        </p:nvPicPr>
+        <p:blipFill>
+          <a:blip r:embed="rId9"/>
+          <a:stretch>
+            <a:fillRect/>
+          </a:stretch>
+        </p:blipFill>
+        <p:spPr>
+          <a:xfrm>
+            <a:off x="5760720" y="4270248"/>
+            <a:ext cx="329184" cy="329184"/>
+          </a:xfrm>
+          <a:prstGeom prst="rect">
+            <a:avLst/>
+          </a:prstGeom>
+        </p:spPr>
+      </p:pic>
+      <p:sp>
+        <p:nvSpPr>
+          <p:cNvPr id="38" name="TextBox 37"/>
+          <p:cNvSpPr txBox="1"/>
+          <p:nvPr/>
+        </p:nvSpPr>
+        <p:spPr>
+          <a:xfrm>
+            <a:off x="6217920" y="4069080"/>
+            <a:ext cx="3291840" cy="731520"/>
+          </a:xfrm>
+          <a:prstGeom prst="rect">
+            <a:avLst/>
+          </a:prstGeom>
+          <a:noFill/>
+        </p:spPr>
+        <p:txBody>
+          <a:bodyPr wrap="square" lIns="0" rIns="0" tIns="0" bIns="0" anchor="ctr">
+            <a:spAutoFit/>
+          </a:bodyPr>
+          <a:lstStyle/>
+          <a:p>
+            <a:pPr algn="l"/>
+            <a:r>
+              <a:rPr sz="1300" b="1">
+                <a:solidFill>
+                  <a:srgbClr val="3D4757"/>
+                </a:solidFill>
+                <a:latin typeface="微软雅黑"/>
+                <a:ea typeface="微软雅黑"/>
+                <a:cs typeface="微软雅黑"/>
+              </a:rPr>
+              <a:t>仍走抢票的捡漏扣位</a:t>
+            </a:r>
+          </a:p>
+        </p:txBody>
+      </p:sp>
+      <p:sp>
+        <p:nvSpPr>
+          <p:cNvPr id="39" name="Rounded Rectangle 38"/>
+          <p:cNvSpPr/>
+          <p:nvPr/>
+        </p:nvSpPr>
+        <p:spPr>
+          <a:xfrm>
+            <a:off x="9601200" y="4251960"/>
+            <a:ext cx="1920240" cy="365760"/>
+          </a:xfrm>
+          <a:prstGeom prst="roundRect">
+            <a:avLst>
+              <a:gd name="adj" fmla="val 50000"/>
+            </a:avLst>
+          </a:prstGeom>
+          <a:solidFill>
+            <a:srgbClr val="FFFFFF"/>
+          </a:solidFill>
+          <a:ln w="12700">
+            <a:solidFill>
+              <a:srgbClr val="FF7A1A"/>
+            </a:solidFill>
+          </a:ln>
+          <a:effectLst/>
+        </p:spPr>
+        <p:style>
+          <a:lnRef idx="1">
+            <a:schemeClr val="accent1"/>
+          </a:lnRef>
+          <a:fillRef idx="3">
+            <a:schemeClr val="accent1"/>
+          </a:fillRef>
+          <a:effectRef idx="2">
+            <a:schemeClr val="accent1"/>
+          </a:effectRef>
+          <a:fontRef idx="minor">
+            <a:schemeClr val="lt1"/>
+          </a:fontRef>
+        </p:style>
+        <p:txBody>
+          <a:bodyPr rtlCol="0" anchor="ctr"/>
+          <a:lstStyle/>
+          <a:p/>
+        </p:txBody>
+      </p:sp>
+      <p:sp>
+        <p:nvSpPr>
+          <p:cNvPr id="40" name="TextBox 39"/>
+          <p:cNvSpPr txBox="1"/>
+          <p:nvPr/>
+        </p:nvSpPr>
+        <p:spPr>
+          <a:xfrm>
+            <a:off x="9601200" y="4251960"/>
+            <a:ext cx="1920240" cy="365760"/>
+          </a:xfrm>
+          <a:prstGeom prst="rect">
+            <a:avLst/>
+          </a:prstGeom>
+          <a:noFill/>
+        </p:spPr>
+        <p:txBody>
+          <a:bodyPr wrap="square" lIns="0" rIns="0" tIns="0" bIns="0" anchor="ctr">
+            <a:spAutoFit/>
+          </a:bodyPr>
+          <a:lstStyle/>
+          <a:p>
+            <a:pPr algn="ctr"/>
+            <a:r>
+              <a:rPr sz="1100" b="1">
+                <a:solidFill>
+                  <a:srgbClr val="FF7A1A"/>
+                </a:solidFill>
+                <a:latin typeface="微软雅黑"/>
+                <a:ea typeface="微软雅黑"/>
+                <a:cs typeface="微软雅黑"/>
+              </a:rPr>
+              <a:t>出票概率【待补充】</a:t>
+            </a:r>
+          </a:p>
+        </p:txBody>
+      </p:sp>
+      <p:sp>
+        <p:nvSpPr>
+          <p:cNvPr id="41" name="Rounded Rectangle 40"/>
+          <p:cNvSpPr/>
+          <p:nvPr/>
+        </p:nvSpPr>
+        <p:spPr>
+          <a:xfrm>
+            <a:off x="4709160" y="5029200"/>
+            <a:ext cx="777240" cy="731520"/>
+          </a:xfrm>
+          <a:prstGeom prst="roundRect">
+            <a:avLst>
+              <a:gd name="adj" fmla="val 20000"/>
+            </a:avLst>
+          </a:prstGeom>
+          <a:solidFill>
+            <a:srgbClr val="287DFA"/>
+          </a:solidFill>
+          <a:ln>
+            <a:noFill/>
+          </a:ln>
+          <a:effectLst/>
+        </p:spPr>
+        <p:style>
+          <a:lnRef idx="1">
+            <a:schemeClr val="accent1"/>
+          </a:lnRef>
+          <a:fillRef idx="3">
+            <a:schemeClr val="accent1"/>
+          </a:fillRef>
+          <a:effectRef idx="2">
+            <a:schemeClr val="accent1"/>
+          </a:effectRef>
+          <a:fontRef idx="minor">
+            <a:schemeClr val="lt1"/>
+          </a:fontRef>
+        </p:style>
+        <p:txBody>
+          <a:bodyPr rtlCol="0" anchor="ctr"/>
+          <a:lstStyle/>
+          <a:p/>
+        </p:txBody>
+      </p:sp>
+      <p:sp>
+        <p:nvSpPr>
+          <p:cNvPr id="42" name="TextBox 41"/>
+          <p:cNvSpPr txBox="1"/>
+          <p:nvPr/>
+        </p:nvSpPr>
+        <p:spPr>
+          <a:xfrm>
+            <a:off x="4709160" y="5029200"/>
+            <a:ext cx="777240" cy="731520"/>
+          </a:xfrm>
+          <a:prstGeom prst="rect">
+            <a:avLst/>
+          </a:prstGeom>
+          <a:noFill/>
+        </p:spPr>
+        <p:txBody>
+          <a:bodyPr wrap="square" lIns="0" rIns="0" tIns="0" bIns="0" anchor="ctr">
+            <a:spAutoFit/>
+          </a:bodyPr>
+          <a:lstStyle/>
+          <a:p>
+            <a:pPr algn="ctr"/>
+            <a:r>
+              <a:rPr sz="1400" b="1">
+                <a:solidFill>
+                  <a:srgbClr val="FFFFFF"/>
+                </a:solidFill>
+                <a:latin typeface="微软雅黑"/>
+                <a:ea typeface="微软雅黑"/>
+                <a:cs typeface="微软雅黑"/>
+              </a:rPr>
+              <a:t>之后</a:t>
+            </a:r>
+          </a:p>
+        </p:txBody>
+      </p:sp>
+      <p:sp>
+        <p:nvSpPr>
+          <p:cNvPr id="43" name="Rounded Rectangle 42"/>
+          <p:cNvSpPr/>
+          <p:nvPr/>
+        </p:nvSpPr>
+        <p:spPr>
+          <a:xfrm>
+            <a:off x="5605272" y="5029200"/>
+            <a:ext cx="6053328" cy="731520"/>
+          </a:xfrm>
+          <a:prstGeom prst="roundRect">
+            <a:avLst>
+              <a:gd name="adj" fmla="val 6000"/>
+            </a:avLst>
+          </a:prstGeom>
+          <a:solidFill>
+            <a:srgbClr val="EAF2FF"/>
+          </a:solidFill>
+          <a:ln w="12700">
+            <a:solidFill>
+              <a:srgbClr val="287DFA"/>
+            </a:solidFill>
+          </a:ln>
+          <a:effectLst/>
+        </p:spPr>
+        <p:style>
+          <a:lnRef idx="1">
+            <a:schemeClr val="accent1"/>
+          </a:lnRef>
+          <a:fillRef idx="3">
+            <a:schemeClr val="accent1"/>
+          </a:fillRef>
+          <a:effectRef idx="2">
+            <a:schemeClr val="accent1"/>
+          </a:effectRef>
+          <a:fontRef idx="minor">
+            <a:schemeClr val="lt1"/>
+          </a:fontRef>
+        </p:style>
+        <p:txBody>
+          <a:bodyPr rtlCol="0" anchor="ctr"/>
+          <a:lstStyle/>
+          <a:p/>
+        </p:txBody>
+      </p:sp>
+      <p:pic>
+        <p:nvPicPr>
+          <p:cNvPr id="44" name="Picture 43" descr="FaCircleCheck_b.png"/>
+          <p:cNvPicPr>
+            <a:picLocks noChangeAspect="1"/>
+          </p:cNvPicPr>
+          <p:nvPr/>
+        </p:nvPicPr>
+        <p:blipFill>
+          <a:blip r:embed="rId10"/>
+          <a:stretch>
+            <a:fillRect/>
+          </a:stretch>
+        </p:blipFill>
+        <p:spPr>
+          <a:xfrm>
+            <a:off x="5760720" y="5230368"/>
+            <a:ext cx="329184" cy="329184"/>
+          </a:xfrm>
+          <a:prstGeom prst="rect">
+            <a:avLst/>
+          </a:prstGeom>
+        </p:spPr>
+      </p:pic>
+      <p:sp>
+        <p:nvSpPr>
+          <p:cNvPr id="45" name="TextBox 44"/>
+          <p:cNvSpPr txBox="1"/>
+          <p:nvPr/>
+        </p:nvSpPr>
+        <p:spPr>
+          <a:xfrm>
+            <a:off x="6217920" y="5029200"/>
+            <a:ext cx="3291840" cy="731520"/>
+          </a:xfrm>
+          <a:prstGeom prst="rect">
+            <a:avLst/>
+          </a:prstGeom>
+          <a:noFill/>
+        </p:spPr>
+        <p:txBody>
+          <a:bodyPr wrap="square" lIns="0" rIns="0" tIns="0" bIns="0" anchor="ctr">
+            <a:spAutoFit/>
+          </a:bodyPr>
+          <a:lstStyle/>
+          <a:p>
+            <a:pPr algn="l"/>
+            <a:r>
+              <a:rPr sz="1300" b="1">
+                <a:solidFill>
+                  <a:srgbClr val="3D4757"/>
+                </a:solidFill>
+                <a:latin typeface="微软雅黑"/>
+                <a:ea typeface="微软雅黑"/>
+                <a:cs typeface="微软雅黑"/>
+              </a:rPr>
+              <a:t>支付宝（非黑名单）订单直接走买票接口</a:t>
+            </a:r>
+          </a:p>
+        </p:txBody>
+      </p:sp>
+      <p:sp>
+        <p:nvSpPr>
+          <p:cNvPr id="46" name="Rounded Rectangle 45"/>
+          <p:cNvSpPr/>
+          <p:nvPr/>
+        </p:nvSpPr>
+        <p:spPr>
+          <a:xfrm>
+            <a:off x="9601200" y="5212080"/>
+            <a:ext cx="1920240" cy="365760"/>
+          </a:xfrm>
+          <a:prstGeom prst="roundRect">
+            <a:avLst>
+              <a:gd name="adj" fmla="val 50000"/>
+            </a:avLst>
+          </a:prstGeom>
+          <a:solidFill>
+            <a:srgbClr val="FFFFFF"/>
+          </a:solidFill>
+          <a:ln w="12700">
+            <a:solidFill>
+              <a:srgbClr val="287DFA"/>
+            </a:solidFill>
+          </a:ln>
+          <a:effectLst/>
+        </p:spPr>
+        <p:style>
+          <a:lnRef idx="1">
+            <a:schemeClr val="accent1"/>
+          </a:lnRef>
+          <a:fillRef idx="3">
+            <a:schemeClr val="accent1"/>
+          </a:fillRef>
+          <a:effectRef idx="2">
+            <a:schemeClr val="accent1"/>
+          </a:effectRef>
+          <a:fontRef idx="minor">
+            <a:schemeClr val="lt1"/>
+          </a:fontRef>
+        </p:style>
+        <p:txBody>
+          <a:bodyPr rtlCol="0" anchor="ctr"/>
+          <a:lstStyle/>
+          <a:p/>
+        </p:txBody>
+      </p:sp>
+      <p:sp>
+        <p:nvSpPr>
+          <p:cNvPr id="47" name="TextBox 46"/>
+          <p:cNvSpPr txBox="1"/>
+          <p:nvPr/>
+        </p:nvSpPr>
+        <p:spPr>
+          <a:xfrm>
+            <a:off x="9601200" y="5212080"/>
+            <a:ext cx="1920240" cy="365760"/>
+          </a:xfrm>
+          <a:prstGeom prst="rect">
+            <a:avLst/>
+          </a:prstGeom>
+          <a:noFill/>
+        </p:spPr>
+        <p:txBody>
+          <a:bodyPr wrap="square" lIns="0" rIns="0" tIns="0" bIns="0" anchor="ctr">
+            <a:spAutoFit/>
+          </a:bodyPr>
+          <a:lstStyle/>
+          <a:p>
+            <a:pPr algn="ctr"/>
+            <a:r>
+              <a:rPr sz="1100" b="1">
+                <a:solidFill>
+                  <a:srgbClr val="287DFA"/>
+                </a:solidFill>
+                <a:latin typeface="微软雅黑"/>
+                <a:ea typeface="微软雅黑"/>
+                <a:cs typeface="微软雅黑"/>
+              </a:rPr>
+              <a:t>上线后增量【待补】</a:t>
             </a:r>
           </a:p>
         </p:txBody>

</xml_diff>